<commit_message>
System Design 101 (vi): stop claiming the four omitted patterns have a lesson in sd-08-011
</commit_message>
<xml_diff>
--- a/system-design-101/vi/lessons/sd-08-011/slides/sd-08-011.pptx
+++ b/system-design-101/vi/lessons/sd-08-011/slides/sd-08-011.pptx
@@ -3203,48 +3203,26 @@
               <a:t> mẫu</a:t>
             </a:r>
             <a:r>
-              <a:rPr lang="en-US" sz="2550" dirty="0" spc="18" kern="0">
-                <a:solidFill>
-                  <a:srgbClr val="14161C"/>
-                </a:solidFill>
-                <a:latin typeface="Be Vietnam Pro" pitchFamily="34" charset="0"/>
-                <a:ea typeface="Be Vietnam Pro" pitchFamily="34" charset="-122"/>
-                <a:cs typeface="Be Vietnam Pro" pitchFamily="34" charset="-120"/>
-              </a:rPr>
-              <a:t> đã</a:t>
-            </a:r>
-            <a:r>
-              <a:rPr lang="en-US" sz="2550" dirty="0" spc="0" kern="0">
-                <a:solidFill>
-                  <a:srgbClr val="14161C"/>
-                </a:solidFill>
-                <a:latin typeface="Be Vietnam Pro" pitchFamily="34" charset="0"/>
-                <a:ea typeface="Be Vietnam Pro" pitchFamily="34" charset="-122"/>
-                <a:cs typeface="Be Vietnam Pro" pitchFamily="34" charset="-120"/>
-              </a:rPr>
-              <a:t> có</a:t>
-            </a:r>
-            <a:r>
-              <a:rPr lang="en-US" sz="2550" dirty="0" spc="-3" kern="0">
-                <a:solidFill>
-                  <a:srgbClr val="14161C"/>
-                </a:solidFill>
-                <a:latin typeface="Be Vietnam Pro" pitchFamily="34" charset="0"/>
-                <a:ea typeface="Be Vietnam Pro" pitchFamily="34" charset="-122"/>
-                <a:cs typeface="Be Vietnam Pro" pitchFamily="34" charset="-120"/>
-              </a:rPr>
-              <a:t> bài</a:t>
-            </a:r>
-            <a:r>
-              <a:rPr lang="en-US" sz="2550" dirty="0" spc="8" kern="0">
-                <a:solidFill>
-                  <a:srgbClr val="14161C"/>
-                </a:solidFill>
-                <a:latin typeface="Be Vietnam Pro" pitchFamily="34" charset="0"/>
-                <a:ea typeface="Be Vietnam Pro" pitchFamily="34" charset="-122"/>
-                <a:cs typeface="Be Vietnam Pro" pitchFamily="34" charset="-120"/>
-              </a:rPr>
-              <a:t> riêng.</a:t>
+              <a:rPr lang="en-US" sz="2550" dirty="0" spc="6" kern="0">
+                <a:solidFill>
+                  <a:srgbClr val="14161C"/>
+                </a:solidFill>
+                <a:latin typeface="Be Vietnam Pro" pitchFamily="34" charset="0"/>
+                <a:ea typeface="Be Vietnam Pro" pitchFamily="34" charset="-122"/>
+                <a:cs typeface="Be Vietnam Pro" pitchFamily="34" charset="-120"/>
+              </a:rPr>
+              <a:t> chưa</a:t>
+            </a:r>
+            <a:r>
+              <a:rPr lang="en-US" sz="2550" dirty="0" spc="-18" kern="0">
+                <a:solidFill>
+                  <a:srgbClr val="14161C"/>
+                </a:solidFill>
+                <a:latin typeface="Be Vietnam Pro" pitchFamily="34" charset="0"/>
+                <a:ea typeface="Be Vietnam Pro" pitchFamily="34" charset="-122"/>
+                <a:cs typeface="Be Vietnam Pro" pitchFamily="34" charset="-120"/>
+              </a:rPr>
+              <a:t> xét.</a:t>
             </a:r>
             <a:endParaRPr lang="en-US" sz="2550" dirty="0"/>
           </a:p>
@@ -11295,18 +11273,7 @@
               <a:t> lại,</a:t>
             </a:r>
             <a:r>
-              <a:rPr lang="en-US" sz="2100" dirty="0" spc="-8" kern="0">
-                <a:solidFill>
-                  <a:srgbClr val="14161C"/>
-                </a:solidFill>
-                <a:latin typeface="Be Vietnam Pro" pitchFamily="34" charset="0"/>
-                <a:ea typeface="Be Vietnam Pro" pitchFamily="34" charset="-122"/>
-                <a:cs typeface="Be Vietnam Pro" pitchFamily="34" charset="-120"/>
-              </a:rPr>
-              <a:t> bỏ</a:t>
-            </a:r>
-            <a:r>
-              <a:rPr lang="en-US" sz="2100" dirty="0" spc="-6" kern="0">
+              <a:rPr lang="en-US" sz="2100" dirty="0" spc="-5" kern="0">
                 <a:solidFill>
                   <a:srgbClr val="14161C"/>
                 </a:solidFill>
@@ -11328,48 +11295,48 @@
               <a:t> mẫu</a:t>
             </a:r>
             <a:r>
-              <a:rPr lang="en-US" sz="2100" dirty="0" spc="13" kern="0">
-                <a:solidFill>
-                  <a:srgbClr val="14161C"/>
-                </a:solidFill>
-                <a:latin typeface="Be Vietnam Pro" pitchFamily="34" charset="0"/>
-                <a:ea typeface="Be Vietnam Pro" pitchFamily="34" charset="-122"/>
-                <a:cs typeface="Be Vietnam Pro" pitchFamily="34" charset="-120"/>
-              </a:rPr>
-              <a:t> đã</a:t>
-            </a:r>
-            <a:r>
-              <a:rPr lang="en-US" sz="2100" dirty="0" spc="-4" kern="0">
-                <a:solidFill>
-                  <a:srgbClr val="14161C"/>
-                </a:solidFill>
-                <a:latin typeface="Be Vietnam Pro" pitchFamily="34" charset="0"/>
-                <a:ea typeface="Be Vietnam Pro" pitchFamily="34" charset="-122"/>
-                <a:cs typeface="Be Vietnam Pro" pitchFamily="34" charset="-120"/>
-              </a:rPr>
-              <a:t> có</a:t>
-            </a:r>
-            <a:r>
-              <a:rPr lang="en-US" sz="2100" dirty="0" spc="-5" kern="0">
-                <a:solidFill>
-                  <a:srgbClr val="14161C"/>
-                </a:solidFill>
-                <a:latin typeface="Be Vietnam Pro" pitchFamily="34" charset="0"/>
-                <a:ea typeface="Be Vietnam Pro" pitchFamily="34" charset="-122"/>
-                <a:cs typeface="Be Vietnam Pro" pitchFamily="34" charset="-120"/>
-              </a:rPr>
-              <a:t> bài</a:t>
-            </a:r>
-            <a:r>
-              <a:rPr lang="en-US" sz="2100" dirty="0" spc="8" kern="0">
-                <a:solidFill>
-                  <a:srgbClr val="14161C"/>
-                </a:solidFill>
-                <a:latin typeface="Be Vietnam Pro" pitchFamily="34" charset="0"/>
-                <a:ea typeface="Be Vietnam Pro" pitchFamily="34" charset="-122"/>
-                <a:cs typeface="Be Vietnam Pro" pitchFamily="34" charset="-120"/>
-              </a:rPr>
-              <a:t> riêng</a:t>
+              <a:rPr lang="en-US" sz="2100" dirty="0" spc="4" kern="0">
+                <a:solidFill>
+                  <a:srgbClr val="14161C"/>
+                </a:solidFill>
+                <a:latin typeface="Be Vietnam Pro" pitchFamily="34" charset="0"/>
+                <a:ea typeface="Be Vietnam Pro" pitchFamily="34" charset="-122"/>
+                <a:cs typeface="Be Vietnam Pro" pitchFamily="34" charset="-120"/>
+              </a:rPr>
+              <a:t> chưa</a:t>
+            </a:r>
+            <a:r>
+              <a:rPr lang="en-US" sz="2100" dirty="0" spc="-21" kern="0">
+                <a:solidFill>
+                  <a:srgbClr val="14161C"/>
+                </a:solidFill>
+                <a:latin typeface="Be Vietnam Pro" pitchFamily="34" charset="0"/>
+                <a:ea typeface="Be Vietnam Pro" pitchFamily="34" charset="-122"/>
+                <a:cs typeface="Be Vietnam Pro" pitchFamily="34" charset="-120"/>
+              </a:rPr>
+              <a:t> xét</a:t>
+            </a:r>
+            <a:r>
+              <a:rPr lang="en-US" sz="2100" dirty="0" spc="-1" kern="0">
+                <a:solidFill>
+                  <a:srgbClr val="14161C"/>
+                </a:solidFill>
+                <a:latin typeface="Be Vietnam Pro" pitchFamily="34" charset="0"/>
+                <a:ea typeface="Be Vietnam Pro" pitchFamily="34" charset="-122"/>
+                <a:cs typeface="Be Vietnam Pro" pitchFamily="34" charset="-120"/>
+              </a:rPr>
+              <a:t> (không nói</a:t>
+            </a:r>
+            <a:r>
+              <a:rPr lang="en-US" sz="2100" dirty="0" spc="-11" kern="0">
+                <a:solidFill>
+                  <a:srgbClr val="14161C"/>
+                </a:solidFill>
+                <a:latin typeface="Be Vietnam Pro" pitchFamily="34" charset="0"/>
+                <a:ea typeface="Be Vietnam Pro" pitchFamily="34" charset="-122"/>
+                <a:cs typeface="Be Vietnam Pro" pitchFamily="34" charset="-120"/>
+              </a:rPr>
+              <a:t> tới)</a:t>
             </a:r>
             <a:endParaRPr lang="en-US" sz="2100" dirty="0"/>
           </a:p>

</xml_diff>